<commit_message>
Presentation mise a jour : 8 tests, evaluation RAG 73%
</commit_message>
<xml_diff>
--- a/docs/presentation_puls_events.pptx
+++ b/docs/presentation_puls_events.pptx
@@ -2405,7 +2405,7 @@
                 <a:ea typeface="Cambria" pitchFamily="34" charset="-122"/>
                 <a:cs typeface="Cambria" pitchFamily="34" charset="-120"/>
               </a:rPr>
-              <a:t>5/5</a:t>
+              <a:t>8/8</a:t>
             </a:r>
             <a:endParaRPr lang="en-US" sz="3600" dirty="0"/>
           </a:p>
@@ -2693,7 +2693,7 @@
                 <a:ea typeface="Cambria" pitchFamily="34" charset="-122"/>
                 <a:cs typeface="Cambria" pitchFamily="34" charset="-120"/>
               </a:rPr>
-              <a:t>Top-3</a:t>
+              <a:t>73%</a:t>
             </a:r>
             <a:endParaRPr lang="en-US" sz="3600" dirty="0"/>
           </a:p>
@@ -2732,7 +2732,7 @@
                 <a:ea typeface="Calibri" pitchFamily="34" charset="-122"/>
                 <a:cs typeface="Calibri" pitchFamily="34" charset="-120"/>
               </a:rPr>
-              <a:t>résultats</a:t>
+              <a:t>pertinence</a:t>
             </a:r>
             <a:endParaRPr lang="en-US" sz="1200" dirty="0"/>
           </a:p>
@@ -2771,7 +2771,7 @@
                 <a:ea typeface="Calibri" pitchFamily="34" charset="-122"/>
                 <a:cs typeface="Calibri" pitchFamily="34" charset="-120"/>
               </a:rPr>
-              <a:t>pertinents par requête</a:t>
+              <a:t>score évaluation RAG</a:t>
             </a:r>
             <a:endParaRPr lang="en-US" sz="1000" dirty="0"/>
           </a:p>
@@ -7821,7 +7821,7 @@
                 <a:ea typeface="Calibri" pitchFamily="34" charset="-122"/>
                 <a:cs typeface="Calibri" pitchFamily="34" charset="-120"/>
               </a:rPr>
-              <a:t>5 / 5 tests passés  ✅</a:t>
+              <a:t>8 / 8 tests passés  ✅</a:t>
             </a:r>
             <a:endParaRPr lang="en-US" sz="1600" dirty="0"/>
           </a:p>

</xml_diff>

<commit_message>
Corrections : 300 evenements, 8 tests, pagination dans toute la doc
</commit_message>
<xml_diff>
--- a/docs/presentation_puls_events.pptx
+++ b/docs/presentation_puls_events.pptx
@@ -2261,7 +2261,7 @@
                 <a:ea typeface="Cambria" pitchFamily="34" charset="-122"/>
                 <a:cs typeface="Cambria" pitchFamily="34" charset="-120"/>
               </a:rPr>
-              <a:t>100</a:t>
+              <a:t>300</a:t>
             </a:r>
             <a:endParaRPr lang="en-US" sz="3600" dirty="0"/>
           </a:p>
@@ -3061,7 +3061,7 @@
                 <a:ea typeface="Calibri" pitchFamily="34" charset="-122"/>
                 <a:cs typeface="Calibri" pitchFamily="34" charset="-120"/>
               </a:rPr>
-              <a:t>Passer de 100 à 500+ événements pour une meilleure couverture</a:t>
+              <a:t>Étendre à 500+ événements via filtres thématiques avancés (pagination déjà implémentée à 300)</a:t>
             </a:r>
             <a:endParaRPr lang="en-US" sz="1100" dirty="0"/>
           </a:p>
@@ -3733,7 +3733,7 @@
                 <a:ea typeface="Calibri" pitchFamily="34" charset="-122"/>
                 <a:cs typeface="Calibri" pitchFamily="34" charset="-120"/>
               </a:rPr>
-              <a:t>✅  100 événements indexés, recherche sémantique opérationnelle</a:t>
+              <a:t>✅  300 événements indexés avec pagination, recherche sémantique opérationnelle</a:t>
             </a:r>
             <a:endParaRPr lang="en-US" sz="1300" dirty="0"/>
           </a:p>
@@ -3772,7 +3772,7 @@
                 <a:ea typeface="Calibri" pitchFamily="34" charset="-122"/>
                 <a:cs typeface="Calibri" pitchFamily="34" charset="-120"/>
               </a:rPr>
-              <a:t>✅  Tests unitaires 5/5 passés</a:t>
+              <a:t>✅  Tests unitaires 8/8 passés</a:t>
             </a:r>
             <a:endParaRPr lang="en-US" sz="1300" dirty="0"/>
           </a:p>
@@ -5982,7 +5982,7 @@
                 <a:ea typeface="Cambria" pitchFamily="34" charset="-122"/>
                 <a:cs typeface="Cambria" pitchFamily="34" charset="-120"/>
               </a:rPr>
-              <a:t>100</a:t>
+              <a:t>300</a:t>
             </a:r>
             <a:endParaRPr lang="en-US" sz="2600" dirty="0"/>
           </a:p>
@@ -6038,7 +6038,7 @@
                 <a:ea typeface="Calibri" pitchFamily="34" charset="-122"/>
                 <a:cs typeface="Calibri" pitchFamily="34" charset="-120"/>
               </a:rPr>
-              <a:t>indexés (POC)</a:t>
+              <a:t>indexés</a:t>
             </a:r>
             <a:endParaRPr lang="en-US" sz="1100" dirty="0"/>
           </a:p>
@@ -7103,7 +7103,7 @@
                 <a:ea typeface="Calibri" pitchFamily="34" charset="-122"/>
                 <a:cs typeface="Calibri" pitchFamily="34" charset="-120"/>
               </a:rPr>
-              <a:t>(100 événements)</a:t>
+              <a:t>(300 événements)</a:t>
             </a:r>
             <a:endParaRPr lang="en-US" sz="1000" dirty="0"/>
           </a:p>
@@ -7835,12 +7835,12 @@
         </p:nvSpPr>
         <p:spPr>
           <a:xfrm>
-            <a:off x="457200" y="1463040"/>
-            <a:ext cx="8412480" cy="502920"/>
+            <a:off x="457200" y="1325880"/>
+            <a:ext cx="8412480" cy="402336"/>
           </a:xfrm>
           <a:prstGeom prst="roundRect">
             <a:avLst>
-              <a:gd name="adj" fmla="val 10909"/>
+              <a:gd name="adj" fmla="val 13636"/>
             </a:avLst>
           </a:prstGeom>
           <a:solidFill>
@@ -7862,8 +7862,8 @@
         </p:nvSpPr>
         <p:spPr>
           <a:xfrm>
-            <a:off x="548640" y="1536192"/>
-            <a:ext cx="365760" cy="347472"/>
+            <a:off x="548640" y="1371600"/>
+            <a:ext cx="365760" cy="310896"/>
           </a:xfrm>
           <a:prstGeom prst="rect">
             <a:avLst/>
@@ -7879,14 +7879,14 @@
               <a:buNone/>
             </a:pPr>
             <a:r>
-              <a:rPr lang="en-US" sz="1400" dirty="0">
+              <a:rPr lang="en-US" sz="1200" dirty="0">
                 <a:solidFill>
                   <a:srgbClr val="000000"/>
                 </a:solidFill>
               </a:rPr>
               <a:t>✅</a:t>
             </a:r>
-            <a:endParaRPr lang="en-US" sz="1400" dirty="0"/>
+            <a:endParaRPr lang="en-US" sz="1200" dirty="0"/>
           </a:p>
         </p:txBody>
       </p:sp>
@@ -7898,8 +7898,8 @@
         </p:nvSpPr>
         <p:spPr>
           <a:xfrm>
-            <a:off x="1051560" y="1508760"/>
-            <a:ext cx="3200400" cy="228600"/>
+            <a:off x="1051560" y="1353312"/>
+            <a:ext cx="3200400" cy="182880"/>
           </a:xfrm>
           <a:prstGeom prst="rect">
             <a:avLst/>
@@ -7915,7 +7915,7 @@
               <a:buNone/>
             </a:pPr>
             <a:r>
-              <a:rPr lang="en-US" sz="1100" b="1" dirty="0">
+              <a:rPr lang="en-US" sz="1000" b="1" dirty="0">
                 <a:solidFill>
                   <a:srgbClr val="1A1F3C"/>
                 </a:solidFill>
@@ -7925,7 +7925,7 @@
               </a:rPr>
               <a:t>test_donnees_non_vides</a:t>
             </a:r>
-            <a:endParaRPr lang="en-US" sz="1100" dirty="0"/>
+            <a:endParaRPr lang="en-US" sz="1000" dirty="0"/>
           </a:p>
         </p:txBody>
       </p:sp>
@@ -7937,8 +7937,8 @@
         </p:nvSpPr>
         <p:spPr>
           <a:xfrm>
-            <a:off x="1051560" y="1709928"/>
-            <a:ext cx="7406640" cy="201168"/>
+            <a:off x="1051560" y="1527048"/>
+            <a:ext cx="7406640" cy="164592"/>
           </a:xfrm>
           <a:prstGeom prst="rect">
             <a:avLst/>
@@ -7954,7 +7954,7 @@
               <a:buNone/>
             </a:pPr>
             <a:r>
-              <a:rPr lang="en-US" sz="1000" dirty="0">
+              <a:rPr lang="en-US" sz="900" dirty="0">
                 <a:solidFill>
                   <a:srgbClr val="8892A4"/>
                 </a:solidFill>
@@ -7964,7 +7964,7 @@
               </a:rPr>
               <a:t>Vérifie que les données ont bien été récupérées</a:t>
             </a:r>
-            <a:endParaRPr lang="en-US" sz="1000" dirty="0"/>
+            <a:endParaRPr lang="en-US" sz="900" dirty="0"/>
           </a:p>
         </p:txBody>
       </p:sp>
@@ -7976,12 +7976,12 @@
         </p:nvSpPr>
         <p:spPr>
           <a:xfrm>
-            <a:off x="457200" y="2048256"/>
-            <a:ext cx="8412480" cy="502920"/>
+            <a:off x="457200" y="1792224"/>
+            <a:ext cx="8412480" cy="402336"/>
           </a:xfrm>
           <a:prstGeom prst="roundRect">
             <a:avLst>
-              <a:gd name="adj" fmla="val 10909"/>
+              <a:gd name="adj" fmla="val 13636"/>
             </a:avLst>
           </a:prstGeom>
           <a:solidFill>
@@ -8003,8 +8003,8 @@
         </p:nvSpPr>
         <p:spPr>
           <a:xfrm>
-            <a:off x="548640" y="2121408"/>
-            <a:ext cx="365760" cy="347472"/>
+            <a:off x="548640" y="1837944"/>
+            <a:ext cx="365760" cy="310896"/>
           </a:xfrm>
           <a:prstGeom prst="rect">
             <a:avLst/>
@@ -8020,14 +8020,14 @@
               <a:buNone/>
             </a:pPr>
             <a:r>
-              <a:rPr lang="en-US" sz="1400" dirty="0">
+              <a:rPr lang="en-US" sz="1200" dirty="0">
                 <a:solidFill>
                   <a:srgbClr val="000000"/>
                 </a:solidFill>
               </a:rPr>
               <a:t>✅</a:t>
             </a:r>
-            <a:endParaRPr lang="en-US" sz="1400" dirty="0"/>
+            <a:endParaRPr lang="en-US" sz="1200" dirty="0"/>
           </a:p>
         </p:txBody>
       </p:sp>
@@ -8039,8 +8039,8 @@
         </p:nvSpPr>
         <p:spPr>
           <a:xfrm>
-            <a:off x="1051560" y="2093976"/>
-            <a:ext cx="3200400" cy="228600"/>
+            <a:off x="1051560" y="1819656"/>
+            <a:ext cx="3200400" cy="182880"/>
           </a:xfrm>
           <a:prstGeom prst="rect">
             <a:avLst/>
@@ -8056,7 +8056,7 @@
               <a:buNone/>
             </a:pPr>
             <a:r>
-              <a:rPr lang="en-US" sz="1100" b="1" dirty="0">
+              <a:rPr lang="en-US" sz="1000" b="1" dirty="0">
                 <a:solidFill>
                   <a:srgbClr val="1A1F3C"/>
                 </a:solidFill>
@@ -8066,7 +8066,7 @@
               </a:rPr>
               <a:t>test_evenements_moins_un_an</a:t>
             </a:r>
-            <a:endParaRPr lang="en-US" sz="1100" dirty="0"/>
+            <a:endParaRPr lang="en-US" sz="1000" dirty="0"/>
           </a:p>
         </p:txBody>
       </p:sp>
@@ -8078,8 +8078,8 @@
         </p:nvSpPr>
         <p:spPr>
           <a:xfrm>
-            <a:off x="1051560" y="2295144"/>
-            <a:ext cx="7406640" cy="201168"/>
+            <a:off x="1051560" y="1993392"/>
+            <a:ext cx="7406640" cy="164592"/>
           </a:xfrm>
           <a:prstGeom prst="rect">
             <a:avLst/>
@@ -8095,7 +8095,7 @@
               <a:buNone/>
             </a:pPr>
             <a:r>
-              <a:rPr lang="en-US" sz="1000" dirty="0">
+              <a:rPr lang="en-US" sz="900" dirty="0">
                 <a:solidFill>
                   <a:srgbClr val="8892A4"/>
                 </a:solidFill>
@@ -8105,7 +8105,7 @@
               </a:rPr>
               <a:t>Vérifie que tous les événements datent de moins d'un an</a:t>
             </a:r>
-            <a:endParaRPr lang="en-US" sz="1000" dirty="0"/>
+            <a:endParaRPr lang="en-US" sz="900" dirty="0"/>
           </a:p>
         </p:txBody>
       </p:sp>
@@ -8117,12 +8117,12 @@
         </p:nvSpPr>
         <p:spPr>
           <a:xfrm>
-            <a:off x="457200" y="2633472"/>
-            <a:ext cx="8412480" cy="502920"/>
+            <a:off x="457200" y="2258568"/>
+            <a:ext cx="8412480" cy="402336"/>
           </a:xfrm>
           <a:prstGeom prst="roundRect">
             <a:avLst>
-              <a:gd name="adj" fmla="val 10909"/>
+              <a:gd name="adj" fmla="val 13636"/>
             </a:avLst>
           </a:prstGeom>
           <a:solidFill>
@@ -8144,8 +8144,8 @@
         </p:nvSpPr>
         <p:spPr>
           <a:xfrm>
-            <a:off x="548640" y="2706624"/>
-            <a:ext cx="365760" cy="347472"/>
+            <a:off x="548640" y="2304288"/>
+            <a:ext cx="365760" cy="310896"/>
           </a:xfrm>
           <a:prstGeom prst="rect">
             <a:avLst/>
@@ -8161,14 +8161,14 @@
               <a:buNone/>
             </a:pPr>
             <a:r>
-              <a:rPr lang="en-US" sz="1400" dirty="0">
+              <a:rPr lang="en-US" sz="1200" dirty="0">
                 <a:solidFill>
                   <a:srgbClr val="000000"/>
                 </a:solidFill>
               </a:rPr>
               <a:t>✅</a:t>
             </a:r>
-            <a:endParaRPr lang="en-US" sz="1400" dirty="0"/>
+            <a:endParaRPr lang="en-US" sz="1200" dirty="0"/>
           </a:p>
         </p:txBody>
       </p:sp>
@@ -8180,8 +8180,8 @@
         </p:nvSpPr>
         <p:spPr>
           <a:xfrm>
-            <a:off x="1051560" y="2679192"/>
-            <a:ext cx="3200400" cy="228600"/>
+            <a:off x="1051560" y="2286000"/>
+            <a:ext cx="3200400" cy="182880"/>
           </a:xfrm>
           <a:prstGeom prst="rect">
             <a:avLst/>
@@ -8197,7 +8197,7 @@
               <a:buNone/>
             </a:pPr>
             <a:r>
-              <a:rPr lang="en-US" sz="1100" b="1" dirty="0">
+              <a:rPr lang="en-US" sz="1000" b="1" dirty="0">
                 <a:solidFill>
                   <a:srgbClr val="1A1F3C"/>
                 </a:solidFill>
@@ -8207,7 +8207,7 @@
               </a:rPr>
               <a:t>test_ville_paris</a:t>
             </a:r>
-            <a:endParaRPr lang="en-US" sz="1100" dirty="0"/>
+            <a:endParaRPr lang="en-US" sz="1000" dirty="0"/>
           </a:p>
         </p:txBody>
       </p:sp>
@@ -8219,8 +8219,8 @@
         </p:nvSpPr>
         <p:spPr>
           <a:xfrm>
-            <a:off x="1051560" y="2880360"/>
-            <a:ext cx="7406640" cy="201168"/>
+            <a:off x="1051560" y="2459736"/>
+            <a:ext cx="7406640" cy="164592"/>
           </a:xfrm>
           <a:prstGeom prst="rect">
             <a:avLst/>
@@ -8236,7 +8236,7 @@
               <a:buNone/>
             </a:pPr>
             <a:r>
-              <a:rPr lang="en-US" sz="1000" dirty="0">
+              <a:rPr lang="en-US" sz="900" dirty="0">
                 <a:solidFill>
                   <a:srgbClr val="8892A4"/>
                 </a:solidFill>
@@ -8246,7 +8246,7 @@
               </a:rPr>
               <a:t>Vérifie que les événements sont dans le Grand Paris</a:t>
             </a:r>
-            <a:endParaRPr lang="en-US" sz="1000" dirty="0"/>
+            <a:endParaRPr lang="en-US" sz="900" dirty="0"/>
           </a:p>
         </p:txBody>
       </p:sp>
@@ -8258,12 +8258,12 @@
         </p:nvSpPr>
         <p:spPr>
           <a:xfrm>
-            <a:off x="457200" y="3218688"/>
-            <a:ext cx="8412480" cy="502920"/>
+            <a:off x="457200" y="2724912"/>
+            <a:ext cx="8412480" cy="402336"/>
           </a:xfrm>
           <a:prstGeom prst="roundRect">
             <a:avLst>
-              <a:gd name="adj" fmla="val 10909"/>
+              <a:gd name="adj" fmla="val 13636"/>
             </a:avLst>
           </a:prstGeom>
           <a:solidFill>
@@ -8285,8 +8285,8 @@
         </p:nvSpPr>
         <p:spPr>
           <a:xfrm>
-            <a:off x="548640" y="3291840"/>
-            <a:ext cx="365760" cy="347472"/>
+            <a:off x="548640" y="2770632"/>
+            <a:ext cx="365760" cy="310896"/>
           </a:xfrm>
           <a:prstGeom prst="rect">
             <a:avLst/>
@@ -8302,14 +8302,14 @@
               <a:buNone/>
             </a:pPr>
             <a:r>
-              <a:rPr lang="en-US" sz="1400" dirty="0">
+              <a:rPr lang="en-US" sz="1200" dirty="0">
                 <a:solidFill>
                   <a:srgbClr val="000000"/>
                 </a:solidFill>
               </a:rPr>
               <a:t>✅</a:t>
             </a:r>
-            <a:endParaRPr lang="en-US" sz="1400" dirty="0"/>
+            <a:endParaRPr lang="en-US" sz="1200" dirty="0"/>
           </a:p>
         </p:txBody>
       </p:sp>
@@ -8321,8 +8321,8 @@
         </p:nvSpPr>
         <p:spPr>
           <a:xfrm>
-            <a:off x="1051560" y="3264408"/>
-            <a:ext cx="3200400" cy="228600"/>
+            <a:off x="1051560" y="2752344"/>
+            <a:ext cx="3200400" cy="182880"/>
           </a:xfrm>
           <a:prstGeom prst="rect">
             <a:avLst/>
@@ -8338,7 +8338,7 @@
               <a:buNone/>
             </a:pPr>
             <a:r>
-              <a:rPr lang="en-US" sz="1100" b="1" dirty="0">
+              <a:rPr lang="en-US" sz="1000" b="1" dirty="0">
                 <a:solidFill>
                   <a:srgbClr val="1A1F3C"/>
                 </a:solidFill>
@@ -8348,7 +8348,7 @@
               </a:rPr>
               <a:t>test_champs_obligatoires</a:t>
             </a:r>
-            <a:endParaRPr lang="en-US" sz="1100" dirty="0"/>
+            <a:endParaRPr lang="en-US" sz="1000" dirty="0"/>
           </a:p>
         </p:txBody>
       </p:sp>
@@ -8360,8 +8360,8 @@
         </p:nvSpPr>
         <p:spPr>
           <a:xfrm>
-            <a:off x="1051560" y="3465576"/>
-            <a:ext cx="7406640" cy="201168"/>
+            <a:off x="1051560" y="2926080"/>
+            <a:ext cx="7406640" cy="164592"/>
           </a:xfrm>
           <a:prstGeom prst="rect">
             <a:avLst/>
@@ -8377,7 +8377,7 @@
               <a:buNone/>
             </a:pPr>
             <a:r>
-              <a:rPr lang="en-US" sz="1000" dirty="0">
+              <a:rPr lang="en-US" sz="900" dirty="0">
                 <a:solidFill>
                   <a:srgbClr val="8892A4"/>
                 </a:solidFill>
@@ -8385,9 +8385,9 @@
                 <a:ea typeface="Calibri" pitchFamily="34" charset="-122"/>
                 <a:cs typeface="Calibri" pitchFamily="34" charset="-120"/>
               </a:rPr>
-              <a:t>Vérifie la présence de tous les champs requis</a:t>
-            </a:r>
-            <a:endParaRPr lang="en-US" sz="1000" dirty="0"/>
+              <a:t>Vérifie la présence des champs titre et texte_complet</a:t>
+            </a:r>
+            <a:endParaRPr lang="en-US" sz="900" dirty="0"/>
           </a:p>
         </p:txBody>
       </p:sp>
@@ -8399,12 +8399,12 @@
         </p:nvSpPr>
         <p:spPr>
           <a:xfrm>
-            <a:off x="457200" y="3803904"/>
-            <a:ext cx="8412480" cy="502920"/>
+            <a:off x="457200" y="3191256"/>
+            <a:ext cx="8412480" cy="402336"/>
           </a:xfrm>
           <a:prstGeom prst="roundRect">
             <a:avLst>
-              <a:gd name="adj" fmla="val 10909"/>
+              <a:gd name="adj" fmla="val 13636"/>
             </a:avLst>
           </a:prstGeom>
           <a:solidFill>
@@ -8426,8 +8426,8 @@
         </p:nvSpPr>
         <p:spPr>
           <a:xfrm>
-            <a:off x="548640" y="3877056"/>
-            <a:ext cx="365760" cy="347472"/>
+            <a:off x="548640" y="3236976"/>
+            <a:ext cx="365760" cy="310896"/>
           </a:xfrm>
           <a:prstGeom prst="rect">
             <a:avLst/>
@@ -8443,14 +8443,14 @@
               <a:buNone/>
             </a:pPr>
             <a:r>
-              <a:rPr lang="en-US" sz="1400" dirty="0">
+              <a:rPr lang="en-US" sz="1200" dirty="0">
                 <a:solidFill>
                   <a:srgbClr val="000000"/>
                 </a:solidFill>
               </a:rPr>
               <a:t>✅</a:t>
             </a:r>
-            <a:endParaRPr lang="en-US" sz="1400" dirty="0"/>
+            <a:endParaRPr lang="en-US" sz="1200" dirty="0"/>
           </a:p>
         </p:txBody>
       </p:sp>
@@ -8462,8 +8462,8 @@
         </p:nvSpPr>
         <p:spPr>
           <a:xfrm>
-            <a:off x="1051560" y="3849624"/>
-            <a:ext cx="3200400" cy="228600"/>
+            <a:off x="1051560" y="3218688"/>
+            <a:ext cx="3200400" cy="182880"/>
           </a:xfrm>
           <a:prstGeom prst="rect">
             <a:avLst/>
@@ -8479,7 +8479,7 @@
               <a:buNone/>
             </a:pPr>
             <a:r>
-              <a:rPr lang="en-US" sz="1100" b="1" dirty="0">
+              <a:rPr lang="en-US" sz="1000" b="1" dirty="0">
                 <a:solidFill>
                   <a:srgbClr val="1A1F3C"/>
                 </a:solidFill>
@@ -8489,7 +8489,7 @@
               </a:rPr>
               <a:t>test_index_faiss_existe</a:t>
             </a:r>
-            <a:endParaRPr lang="en-US" sz="1100" dirty="0"/>
+            <a:endParaRPr lang="en-US" sz="1000" dirty="0"/>
           </a:p>
         </p:txBody>
       </p:sp>
@@ -8501,8 +8501,8 @@
         </p:nvSpPr>
         <p:spPr>
           <a:xfrm>
-            <a:off x="1051560" y="4050792"/>
-            <a:ext cx="7406640" cy="201168"/>
+            <a:off x="1051560" y="3392424"/>
+            <a:ext cx="7406640" cy="164592"/>
           </a:xfrm>
           <a:prstGeom prst="rect">
             <a:avLst/>
@@ -8518,7 +8518,7 @@
               <a:buNone/>
             </a:pPr>
             <a:r>
-              <a:rPr lang="en-US" sz="1000" dirty="0">
+              <a:rPr lang="en-US" sz="900" dirty="0">
                 <a:solidFill>
                   <a:srgbClr val="8892A4"/>
                 </a:solidFill>
@@ -8528,7 +8528,430 @@
               </a:rPr>
               <a:t>Vérifie que l'index FAISS a bien été créé</a:t>
             </a:r>
+            <a:endParaRPr lang="en-US" sz="900" dirty="0"/>
+          </a:p>
+        </p:txBody>
+      </p:sp>
+      <p:sp>
+        <p:nvSpPr>
+          <p:cNvPr id="24" name="Shape 22"/>
+          <p:cNvSpPr/>
+          <p:nvPr/>
+        </p:nvSpPr>
+        <p:spPr>
+          <a:xfrm>
+            <a:off x="457200" y="3657600"/>
+            <a:ext cx="8412480" cy="402336"/>
+          </a:xfrm>
+          <a:prstGeom prst="roundRect">
+            <a:avLst>
+              <a:gd name="adj" fmla="val 13636"/>
+            </a:avLst>
+          </a:prstGeom>
+          <a:solidFill>
+            <a:srgbClr val="FFFFFF"/>
+          </a:solidFill>
+          <a:ln w="12700">
+            <a:solidFill>
+              <a:srgbClr val="D0D8F0"/>
+            </a:solidFill>
+            <a:prstDash val="solid"/>
+          </a:ln>
+        </p:spPr>
+      </p:sp>
+      <p:sp>
+        <p:nvSpPr>
+          <p:cNvPr id="25" name="Text 23"/>
+          <p:cNvSpPr txBox="1"/>
+          <p:nvPr/>
+        </p:nvSpPr>
+        <p:spPr>
+          <a:xfrm>
+            <a:off x="548640" y="3703320"/>
+            <a:ext cx="365760" cy="310896"/>
+          </a:xfrm>
+          <a:prstGeom prst="rect">
+            <a:avLst/>
+          </a:prstGeom>
+          <a:noFill/>
+          <a:ln/>
+        </p:spPr>
+        <p:txBody>
+          <a:bodyPr wrap="square" rtlCol="0" anchor="ctr"/>
+          <a:lstStyle/>
+          <a:p>
+            <a:pPr algn="ctr" indent="0" marL="0">
+              <a:buNone/>
+            </a:pPr>
+            <a:r>
+              <a:rPr lang="en-US" sz="1200" dirty="0">
+                <a:solidFill>
+                  <a:srgbClr val="000000"/>
+                </a:solidFill>
+              </a:rPr>
+              <a:t>✅</a:t>
+            </a:r>
+            <a:endParaRPr lang="en-US" sz="1200" dirty="0"/>
+          </a:p>
+        </p:txBody>
+      </p:sp>
+      <p:sp>
+        <p:nvSpPr>
+          <p:cNvPr id="26" name="Text 24"/>
+          <p:cNvSpPr txBox="1"/>
+          <p:nvPr/>
+        </p:nvSpPr>
+        <p:spPr>
+          <a:xfrm>
+            <a:off x="1051560" y="3685032"/>
+            <a:ext cx="3200400" cy="182880"/>
+          </a:xfrm>
+          <a:prstGeom prst="rect">
+            <a:avLst/>
+          </a:prstGeom>
+          <a:noFill/>
+          <a:ln/>
+        </p:spPr>
+        <p:txBody>
+          <a:bodyPr wrap="square" rtlCol="0" anchor="ctr"/>
+          <a:lstStyle/>
+          <a:p>
+            <a:pPr indent="0" marL="0">
+              <a:buNone/>
+            </a:pPr>
+            <a:r>
+              <a:rPr lang="en-US" sz="1000" b="1" dirty="0">
+                <a:solidFill>
+                  <a:srgbClr val="1A1F3C"/>
+                </a:solidFill>
+                <a:latin typeface="Courier New" pitchFamily="34" charset="0"/>
+                <a:ea typeface="Courier New" pitchFamily="34" charset="-122"/>
+                <a:cs typeface="Courier New" pitchFamily="34" charset="-120"/>
+              </a:rPr>
+              <a:t>test_recherche_vectorielle</a:t>
+            </a:r>
             <a:endParaRPr lang="en-US" sz="1000" dirty="0"/>
+          </a:p>
+        </p:txBody>
+      </p:sp>
+      <p:sp>
+        <p:nvSpPr>
+          <p:cNvPr id="27" name="Text 25"/>
+          <p:cNvSpPr txBox="1"/>
+          <p:nvPr/>
+        </p:nvSpPr>
+        <p:spPr>
+          <a:xfrm>
+            <a:off x="1051560" y="3858768"/>
+            <a:ext cx="7406640" cy="164592"/>
+          </a:xfrm>
+          <a:prstGeom prst="rect">
+            <a:avLst/>
+          </a:prstGeom>
+          <a:noFill/>
+          <a:ln/>
+        </p:spPr>
+        <p:txBody>
+          <a:bodyPr wrap="square" rtlCol="0" anchor="ctr"/>
+          <a:lstStyle/>
+          <a:p>
+            <a:pPr indent="0" marL="0">
+              <a:buNone/>
+            </a:pPr>
+            <a:r>
+              <a:rPr lang="en-US" sz="900" dirty="0">
+                <a:solidFill>
+                  <a:srgbClr val="8892A4"/>
+                </a:solidFill>
+                <a:latin typeface="Calibri" pitchFamily="34" charset="0"/>
+                <a:ea typeface="Calibri" pitchFamily="34" charset="-122"/>
+                <a:cs typeface="Calibri" pitchFamily="34" charset="-120"/>
+              </a:rPr>
+              <a:t>Vérifie que la recherche FAISS retourne 3 résultats valides</a:t>
+            </a:r>
+            <a:endParaRPr lang="en-US" sz="900" dirty="0"/>
+          </a:p>
+        </p:txBody>
+      </p:sp>
+      <p:sp>
+        <p:nvSpPr>
+          <p:cNvPr id="28" name="Shape 26"/>
+          <p:cNvSpPr/>
+          <p:nvPr/>
+        </p:nvSpPr>
+        <p:spPr>
+          <a:xfrm>
+            <a:off x="457200" y="4123944"/>
+            <a:ext cx="8412480" cy="402336"/>
+          </a:xfrm>
+          <a:prstGeom prst="roundRect">
+            <a:avLst>
+              <a:gd name="adj" fmla="val 13636"/>
+            </a:avLst>
+          </a:prstGeom>
+          <a:solidFill>
+            <a:srgbClr val="FFFFFF"/>
+          </a:solidFill>
+          <a:ln w="12700">
+            <a:solidFill>
+              <a:srgbClr val="D0D8F0"/>
+            </a:solidFill>
+            <a:prstDash val="solid"/>
+          </a:ln>
+        </p:spPr>
+      </p:sp>
+      <p:sp>
+        <p:nvSpPr>
+          <p:cNvPr id="29" name="Text 27"/>
+          <p:cNvSpPr txBox="1"/>
+          <p:nvPr/>
+        </p:nvSpPr>
+        <p:spPr>
+          <a:xfrm>
+            <a:off x="548640" y="4169664"/>
+            <a:ext cx="365760" cy="310896"/>
+          </a:xfrm>
+          <a:prstGeom prst="rect">
+            <a:avLst/>
+          </a:prstGeom>
+          <a:noFill/>
+          <a:ln/>
+        </p:spPr>
+        <p:txBody>
+          <a:bodyPr wrap="square" rtlCol="0" anchor="ctr"/>
+          <a:lstStyle/>
+          <a:p>
+            <a:pPr algn="ctr" indent="0" marL="0">
+              <a:buNone/>
+            </a:pPr>
+            <a:r>
+              <a:rPr lang="en-US" sz="1200" dirty="0">
+                <a:solidFill>
+                  <a:srgbClr val="000000"/>
+                </a:solidFill>
+              </a:rPr>
+              <a:t>✅</a:t>
+            </a:r>
+            <a:endParaRPr lang="en-US" sz="1200" dirty="0"/>
+          </a:p>
+        </p:txBody>
+      </p:sp>
+      <p:sp>
+        <p:nvSpPr>
+          <p:cNvPr id="30" name="Text 28"/>
+          <p:cNvSpPr txBox="1"/>
+          <p:nvPr/>
+        </p:nvSpPr>
+        <p:spPr>
+          <a:xfrm>
+            <a:off x="1051560" y="4151376"/>
+            <a:ext cx="3200400" cy="182880"/>
+          </a:xfrm>
+          <a:prstGeom prst="rect">
+            <a:avLst/>
+          </a:prstGeom>
+          <a:noFill/>
+          <a:ln/>
+        </p:spPr>
+        <p:txBody>
+          <a:bodyPr wrap="square" rtlCol="0" anchor="ctr"/>
+          <a:lstStyle/>
+          <a:p>
+            <a:pPr indent="0" marL="0">
+              <a:buNone/>
+            </a:pPr>
+            <a:r>
+              <a:rPr lang="en-US" sz="1000" b="1" dirty="0">
+                <a:solidFill>
+                  <a:srgbClr val="1A1F3C"/>
+                </a:solidFill>
+                <a:latin typeface="Courier New" pitchFamily="34" charset="0"/>
+                <a:ea typeface="Courier New" pitchFamily="34" charset="-122"/>
+                <a:cs typeface="Courier New" pitchFamily="34" charset="-120"/>
+              </a:rPr>
+              <a:t>test_texte_complet_non_vide</a:t>
+            </a:r>
+            <a:endParaRPr lang="en-US" sz="1000" dirty="0"/>
+          </a:p>
+        </p:txBody>
+      </p:sp>
+      <p:sp>
+        <p:nvSpPr>
+          <p:cNvPr id="31" name="Text 29"/>
+          <p:cNvSpPr txBox="1"/>
+          <p:nvPr/>
+        </p:nvSpPr>
+        <p:spPr>
+          <a:xfrm>
+            <a:off x="1051560" y="4325112"/>
+            <a:ext cx="7406640" cy="164592"/>
+          </a:xfrm>
+          <a:prstGeom prst="rect">
+            <a:avLst/>
+          </a:prstGeom>
+          <a:noFill/>
+          <a:ln/>
+        </p:spPr>
+        <p:txBody>
+          <a:bodyPr wrap="square" rtlCol="0" anchor="ctr"/>
+          <a:lstStyle/>
+          <a:p>
+            <a:pPr indent="0" marL="0">
+              <a:buNone/>
+            </a:pPr>
+            <a:r>
+              <a:rPr lang="en-US" sz="900" dirty="0">
+                <a:solidFill>
+                  <a:srgbClr val="8892A4"/>
+                </a:solidFill>
+                <a:latin typeface="Calibri" pitchFamily="34" charset="0"/>
+                <a:ea typeface="Calibri" pitchFamily="34" charset="-122"/>
+                <a:cs typeface="Calibri" pitchFamily="34" charset="-120"/>
+              </a:rPr>
+              <a:t>Vérifie la longueur minimale du texte_complet</a:t>
+            </a:r>
+            <a:endParaRPr lang="en-US" sz="900" dirty="0"/>
+          </a:p>
+        </p:txBody>
+      </p:sp>
+      <p:sp>
+        <p:nvSpPr>
+          <p:cNvPr id="32" name="Shape 30"/>
+          <p:cNvSpPr/>
+          <p:nvPr/>
+        </p:nvSpPr>
+        <p:spPr>
+          <a:xfrm>
+            <a:off x="457200" y="4590288"/>
+            <a:ext cx="8412480" cy="402336"/>
+          </a:xfrm>
+          <a:prstGeom prst="roundRect">
+            <a:avLst>
+              <a:gd name="adj" fmla="val 13636"/>
+            </a:avLst>
+          </a:prstGeom>
+          <a:solidFill>
+            <a:srgbClr val="FFFFFF"/>
+          </a:solidFill>
+          <a:ln w="12700">
+            <a:solidFill>
+              <a:srgbClr val="D0D8F0"/>
+            </a:solidFill>
+            <a:prstDash val="solid"/>
+          </a:ln>
+        </p:spPr>
+      </p:sp>
+      <p:sp>
+        <p:nvSpPr>
+          <p:cNvPr id="33" name="Text 31"/>
+          <p:cNvSpPr txBox="1"/>
+          <p:nvPr/>
+        </p:nvSpPr>
+        <p:spPr>
+          <a:xfrm>
+            <a:off x="548640" y="4636008"/>
+            <a:ext cx="365760" cy="310896"/>
+          </a:xfrm>
+          <a:prstGeom prst="rect">
+            <a:avLst/>
+          </a:prstGeom>
+          <a:noFill/>
+          <a:ln/>
+        </p:spPr>
+        <p:txBody>
+          <a:bodyPr wrap="square" rtlCol="0" anchor="ctr"/>
+          <a:lstStyle/>
+          <a:p>
+            <a:pPr algn="ctr" indent="0" marL="0">
+              <a:buNone/>
+            </a:pPr>
+            <a:r>
+              <a:rPr lang="en-US" sz="1200" dirty="0">
+                <a:solidFill>
+                  <a:srgbClr val="000000"/>
+                </a:solidFill>
+              </a:rPr>
+              <a:t>✅</a:t>
+            </a:r>
+            <a:endParaRPr lang="en-US" sz="1200" dirty="0"/>
+          </a:p>
+        </p:txBody>
+      </p:sp>
+      <p:sp>
+        <p:nvSpPr>
+          <p:cNvPr id="34" name="Text 32"/>
+          <p:cNvSpPr txBox="1"/>
+          <p:nvPr/>
+        </p:nvSpPr>
+        <p:spPr>
+          <a:xfrm>
+            <a:off x="1051560" y="4617720"/>
+            <a:ext cx="3200400" cy="182880"/>
+          </a:xfrm>
+          <a:prstGeom prst="rect">
+            <a:avLst/>
+          </a:prstGeom>
+          <a:noFill/>
+          <a:ln/>
+        </p:spPr>
+        <p:txBody>
+          <a:bodyPr wrap="square" rtlCol="0" anchor="ctr"/>
+          <a:lstStyle/>
+          <a:p>
+            <a:pPr indent="0" marL="0">
+              <a:buNone/>
+            </a:pPr>
+            <a:r>
+              <a:rPr lang="en-US" sz="1000" b="1" dirty="0">
+                <a:solidFill>
+                  <a:srgbClr val="1A1F3C"/>
+                </a:solidFill>
+                <a:latin typeface="Courier New" pitchFamily="34" charset="0"/>
+                <a:ea typeface="Courier New" pitchFamily="34" charset="-122"/>
+                <a:cs typeface="Courier New" pitchFamily="34" charset="-120"/>
+              </a:rPr>
+              <a:t>test_gestion_champ_manquant</a:t>
+            </a:r>
+            <a:endParaRPr lang="en-US" sz="1000" dirty="0"/>
+          </a:p>
+        </p:txBody>
+      </p:sp>
+      <p:sp>
+        <p:nvSpPr>
+          <p:cNvPr id="35" name="Text 33"/>
+          <p:cNvSpPr txBox="1"/>
+          <p:nvPr/>
+        </p:nvSpPr>
+        <p:spPr>
+          <a:xfrm>
+            <a:off x="1051560" y="4791456"/>
+            <a:ext cx="7406640" cy="164592"/>
+          </a:xfrm>
+          <a:prstGeom prst="rect">
+            <a:avLst/>
+          </a:prstGeom>
+          <a:noFill/>
+          <a:ln/>
+        </p:spPr>
+        <p:txBody>
+          <a:bodyPr wrap="square" rtlCol="0" anchor="ctr"/>
+          <a:lstStyle/>
+          <a:p>
+            <a:pPr indent="0" marL="0">
+              <a:buNone/>
+            </a:pPr>
+            <a:r>
+              <a:rPr lang="en-US" sz="900" dirty="0">
+                <a:solidFill>
+                  <a:srgbClr val="8892A4"/>
+                </a:solidFill>
+                <a:latin typeface="Calibri" pitchFamily="34" charset="0"/>
+                <a:ea typeface="Calibri" pitchFamily="34" charset="-122"/>
+                <a:cs typeface="Calibri" pitchFamily="34" charset="-120"/>
+              </a:rPr>
+              <a:t>Vérifie la robustesse aux champs absents ou vides</a:t>
+            </a:r>
+            <a:endParaRPr lang="en-US" sz="900" dirty="0"/>
           </a:p>
         </p:txBody>
       </p:sp>

</xml_diff>